<commit_message>
update (PRESENTACIÓN PDF )
</commit_message>
<xml_diff>
--- a/Presentación.pptx
+++ b/Presentación.pptx
@@ -348,7 +348,7 @@
           <a:p>
             <a:fld id="{5BCAD085-E8A6-8845-BD4E-CB4CCA059FC4}" type="datetimeFigureOut">
               <a:rPr lang="en-US" smtClean="0"/>
-              <a:t>3/5/2026</a:t>
+              <a:t>3/7/2026</a:t>
             </a:fld>
             <a:endParaRPr lang="en-US"/>
           </a:p>
@@ -639,7 +639,7 @@
           <a:p>
             <a:fld id="{5BCAD085-E8A6-8845-BD4E-CB4CCA059FC4}" type="datetimeFigureOut">
               <a:rPr lang="en-US" smtClean="0"/>
-              <a:t>3/5/2026</a:t>
+              <a:t>3/7/2026</a:t>
             </a:fld>
             <a:endParaRPr lang="en-US"/>
           </a:p>
@@ -903,7 +903,7 @@
           <a:p>
             <a:fld id="{5BCAD085-E8A6-8845-BD4E-CB4CCA059FC4}" type="datetimeFigureOut">
               <a:rPr lang="en-US" smtClean="0"/>
-              <a:t>3/5/2026</a:t>
+              <a:t>3/7/2026</a:t>
             </a:fld>
             <a:endParaRPr lang="en-US"/>
           </a:p>
@@ -1463,7 +1463,7 @@
           <a:p>
             <a:fld id="{5BCAD085-E8A6-8845-BD4E-CB4CCA059FC4}" type="datetimeFigureOut">
               <a:rPr lang="en-US" smtClean="0"/>
-              <a:t>3/5/2026</a:t>
+              <a:t>3/7/2026</a:t>
             </a:fld>
             <a:endParaRPr lang="en-US"/>
           </a:p>
@@ -1722,7 +1722,7 @@
           <a:p>
             <a:fld id="{5BCAD085-E8A6-8845-BD4E-CB4CCA059FC4}" type="datetimeFigureOut">
               <a:rPr lang="en-US" smtClean="0"/>
-              <a:t>3/5/2026</a:t>
+              <a:t>3/7/2026</a:t>
             </a:fld>
             <a:endParaRPr lang="en-US"/>
           </a:p>
@@ -2298,7 +2298,7 @@
           <a:p>
             <a:fld id="{5BCAD085-E8A6-8845-BD4E-CB4CCA059FC4}" type="datetimeFigureOut">
               <a:rPr lang="en-US" smtClean="0"/>
-              <a:t>3/5/2026</a:t>
+              <a:t>3/7/2026</a:t>
             </a:fld>
             <a:endParaRPr lang="en-US"/>
           </a:p>
@@ -2630,7 +2630,7 @@
           <a:p>
             <a:fld id="{5BCAD085-E8A6-8845-BD4E-CB4CCA059FC4}" type="datetimeFigureOut">
               <a:rPr lang="en-US" smtClean="0"/>
-              <a:t>3/5/2026</a:t>
+              <a:t>3/7/2026</a:t>
             </a:fld>
             <a:endParaRPr lang="en-US"/>
           </a:p>
@@ -2805,7 +2805,7 @@
           <a:p>
             <a:fld id="{5BCAD085-E8A6-8845-BD4E-CB4CCA059FC4}" type="datetimeFigureOut">
               <a:rPr lang="en-US" smtClean="0"/>
-              <a:t>3/5/2026</a:t>
+              <a:t>3/7/2026</a:t>
             </a:fld>
             <a:endParaRPr lang="en-US"/>
           </a:p>
@@ -2985,7 +2985,7 @@
           <a:p>
             <a:fld id="{5BCAD085-E8A6-8845-BD4E-CB4CCA059FC4}" type="datetimeFigureOut">
               <a:rPr lang="en-US" smtClean="0"/>
-              <a:t>3/5/2026</a:t>
+              <a:t>3/7/2026</a:t>
             </a:fld>
             <a:endParaRPr lang="en-US"/>
           </a:p>
@@ -3155,7 +3155,7 @@
           <a:p>
             <a:fld id="{5BCAD085-E8A6-8845-BD4E-CB4CCA059FC4}" type="datetimeFigureOut">
               <a:rPr lang="en-US" smtClean="0"/>
-              <a:t>3/5/2026</a:t>
+              <a:t>3/7/2026</a:t>
             </a:fld>
             <a:endParaRPr lang="en-US"/>
           </a:p>
@@ -3414,7 +3414,7 @@
           <a:p>
             <a:fld id="{5BCAD085-E8A6-8845-BD4E-CB4CCA059FC4}" type="datetimeFigureOut">
               <a:rPr lang="en-US" smtClean="0"/>
-              <a:t>3/5/2026</a:t>
+              <a:t>3/7/2026</a:t>
             </a:fld>
             <a:endParaRPr lang="en-US"/>
           </a:p>
@@ -3706,7 +3706,7 @@
           <a:p>
             <a:fld id="{5BCAD085-E8A6-8845-BD4E-CB4CCA059FC4}" type="datetimeFigureOut">
               <a:rPr lang="en-US" smtClean="0"/>
-              <a:t>3/5/2026</a:t>
+              <a:t>3/7/2026</a:t>
             </a:fld>
             <a:endParaRPr lang="en-US"/>
           </a:p>
@@ -4136,7 +4136,7 @@
           <a:p>
             <a:fld id="{5BCAD085-E8A6-8845-BD4E-CB4CCA059FC4}" type="datetimeFigureOut">
               <a:rPr lang="en-US" smtClean="0"/>
-              <a:t>3/5/2026</a:t>
+              <a:t>3/7/2026</a:t>
             </a:fld>
             <a:endParaRPr lang="en-US"/>
           </a:p>
@@ -4260,7 +4260,7 @@
           <a:p>
             <a:fld id="{5BCAD085-E8A6-8845-BD4E-CB4CCA059FC4}" type="datetimeFigureOut">
               <a:rPr lang="en-US" smtClean="0"/>
-              <a:t>3/5/2026</a:t>
+              <a:t>3/7/2026</a:t>
             </a:fld>
             <a:endParaRPr lang="en-US"/>
           </a:p>
@@ -4355,7 +4355,7 @@
           <a:p>
             <a:fld id="{5BCAD085-E8A6-8845-BD4E-CB4CCA059FC4}" type="datetimeFigureOut">
               <a:rPr lang="en-US" smtClean="0"/>
-              <a:t>3/5/2026</a:t>
+              <a:t>3/7/2026</a:t>
             </a:fld>
             <a:endParaRPr lang="en-US"/>
           </a:p>
@@ -4638,7 +4638,7 @@
           <a:p>
             <a:fld id="{5BCAD085-E8A6-8845-BD4E-CB4CCA059FC4}" type="datetimeFigureOut">
               <a:rPr lang="en-US" smtClean="0"/>
-              <a:t>3/5/2026</a:t>
+              <a:t>3/7/2026</a:t>
             </a:fld>
             <a:endParaRPr lang="en-US"/>
           </a:p>
@@ -4929,7 +4929,7 @@
           <a:p>
             <a:fld id="{5BCAD085-E8A6-8845-BD4E-CB4CCA059FC4}" type="datetimeFigureOut">
               <a:rPr lang="en-US" smtClean="0"/>
-              <a:t>3/5/2026</a:t>
+              <a:t>3/7/2026</a:t>
             </a:fld>
             <a:endParaRPr lang="en-US"/>
           </a:p>
@@ -5160,7 +5160,7 @@
           <a:p>
             <a:fld id="{5BCAD085-E8A6-8845-BD4E-CB4CCA059FC4}" type="datetimeFigureOut">
               <a:rPr lang="en-US" smtClean="0"/>
-              <a:t>3/5/2026</a:t>
+              <a:t>3/7/2026</a:t>
             </a:fld>
             <a:endParaRPr lang="en-US"/>
           </a:p>
@@ -6031,19 +6031,17 @@
       </p:sp>
       <p:pic>
         <p:nvPicPr>
-          <p:cNvPr id="7" name="Marcador de contenido 6">
+          <p:cNvPr id="6" name="Imagen 5">
             <a:extLst>
               <a:ext uri="{FF2B5EF4-FFF2-40B4-BE49-F238E27FC236}">
-                <a16:creationId xmlns:a16="http://schemas.microsoft.com/office/drawing/2014/main" id="{F18DA9D7-CACF-B58D-BC34-B3C3EF667FFC}"/>
+                <a16:creationId xmlns:a16="http://schemas.microsoft.com/office/drawing/2014/main" id="{12F907CB-9EA4-6E81-A871-34043291A621}"/>
               </a:ext>
             </a:extLst>
           </p:cNvPr>
           <p:cNvPicPr>
-            <a:picLocks noGrp="1" noChangeAspect="1"/>
+            <a:picLocks noChangeAspect="1"/>
           </p:cNvPicPr>
-          <p:nvPr>
-            <p:ph idx="1"/>
-          </p:nvPr>
+          <p:nvPr/>
         </p:nvPicPr>
         <p:blipFill>
           <a:blip r:embed="rId2"/>
@@ -6053,8 +6051,8 @@
         </p:blipFill>
         <p:spPr>
           <a:xfrm>
-            <a:off x="1927797" y="1669948"/>
-            <a:ext cx="5288406" cy="4592034"/>
+            <a:off x="932688" y="2141661"/>
+            <a:ext cx="7278624" cy="3265177"/>
           </a:xfrm>
           <a:prstGeom prst="rect">
             <a:avLst/>

</xml_diff>